<commit_message>
feat: translate pitch deck to English for international jury
</commit_message>
<xml_diff>
--- a/download/arthavest-pitch-deck.pptx
+++ b/download/arthavest-pitch-deck.pptx
@@ -509,11 +509,11 @@
           <a:p>
             <a:r>
               <a:rPr lang="en-US" dirty="0"/>
-              <a:t>- Hook: UMKM Indonesia berukuran raksasa (64 juta) tapi underfunded — parafrasekan paradox ini di detik pertama.
-- Tegaskan keunikan Sui: SuiStream adalah composable money stream primitive — bukan sekedar payment channel.
-- Combo produk: marketplace (aplikasi) + SuiStream (primitive) — dua lapisan yang saling memperkuat.
-- Sampaikan tagline "Profit mengalir per detik" sebagai janji inti produk.
-- Sebut stats kunci: 6 UMKM terverifikasi, 47-312 investor/UMKM, 18-23% estimasi APY.</a:t>
+              <a:t>- Hook: Indonesian MSMEs are massive (64 million) but underfunded — paraphrase this paradox in the first second.
+- Emphasize Sui's uniqueness: SuiStream is a composable money stream primitive — not just a payment channel.
+- Product combo: marketplace (app) + SuiStream (primitive) — two layers that reinforce each other.
+- Deliver the tagline "Profits flow per second" as the product's core promise.
+- Mention key stats: 6 verified MSMEs, 47-312 investors per MSME, 18-23% estimated APY.</a:t>
             </a:r>
             <a:endParaRPr lang="en-US" dirty="0"/>
           </a:p>
@@ -601,11 +601,11 @@
           <a:p>
             <a:r>
               <a:rPr lang="en-US" dirty="0"/>
-              <a:t>- Buka dengan paradox: 64 juta UMKM = 60% PDB tapi akses kredit di bawah 12%.
-- Jelaskan funding gap Rp 1.2Q tahunan — pasar terabaikan, bukan pasar kecil.
-- Tegaskan demand sisi investor: Gen Z &amp; milenial crypto-native butuh akses investasi kecil.
-- Bandingkan tiga jalur lama (bank, saham publik, crowdfunding) — semuanya punya barrier.
-- Transisi ke solusi: butuh marketplace fraksional + distribusi profit real-time.</a:t>
+              <a:t>- Open with the paradox: 64 million MSMEs = 60% of GDP but credit access below 12%.
+- Explain the Rp 1.2Q annual funding gap — a neglected market, not a small market.
+- Emphasize investor-side demand: crypto-native Gen Z &amp; millennials need small-ticket investment access.
+- Compare the three legacy channels (bank, public stocks, crowdfunding) — all have barriers.
+- Transition to the solution: need a fractional marketplace + real-time profit distribution.</a:t>
             </a:r>
             <a:endParaRPr lang="en-US" dirty="0"/>
           </a:p>
@@ -693,11 +693,11 @@
           <a:p>
             <a:r>
               <a:rPr lang="en-US" dirty="0"/>
-              <a:t>- Jelaskan kenapa combo dua lapisan penting: primitive reusable untuk app lain, app showcase primitive.
-- SuiStream bisa dipakai aplikasi lain (gaji, langganan, rental) — bukan hanya Arthavest.
-- Distribusi profit dieksekusi atomik via PTB — tidak ada window partial failure.
-- Walrus proof di langkah 3 jadi audit trail immutable — tidak bisa manipulasi laporan.
-- Highlight step 5: withdraw sub-second adalah pengalaman investor yang membedakan dari EVM.</a:t>
+              <a:t>- Explain why the two-layer combo matters: reusable primitive for other apps, app showcases the primitive.
+- SuiStream can be used by other apps (payroll, subscriptions, rentals) — not just Arthavest.
+- Profit distribution executes atomically via PTB — no partial failure window.
+- Walrus proof in step 3 serves as an immutable audit trail — reports cannot be manipulated.
+- Highlight step 5: sub-second withdrawal is the investor experience that sets us apart from EVM.</a:t>
             </a:r>
             <a:endParaRPr lang="en-US" dirty="0"/>
           </a:p>
@@ -785,11 +785,11 @@
           <a:p>
             <a:r>
               <a:rPr lang="en-US" dirty="0"/>
-              <a:t>- Pandu juri navigasi 5 tab berurutan: Marketplace → Portfolio → Dashboard UMKM → Pasar Sekunder → DAO Jury.
-- Sebut wallet auto-connect via zkLogin — juri tidak perlu install apapun, tinggal klik Google.
-- Highlight DeepBook sebagai bonus fitur pasar sekunder (likuiditas tanpa exit window).
-- Highlight DAO Jury sebagai bonus governance — trust layer untuk laporan profit UMKM.
-- Onboard UMKM (tile 6) tunjukkan Walrus upload flow — audit trail immutable untuk dokumen legal.</a:t>
+              <a:t>- Guide the jury through 5 tabs in sequence: Marketplace → Portfolio → MSME Dashboard → Secondary Market → DAO Jury.
+- Mention wallet auto-connect via zkLogin — jury doesn't need to install anything, just click Google.
+- Highlight DeepBook as a bonus feature for the secondary market (liquidity without exit windows).
+- Highlight DAO Jury as a bonus governance feature — trust layer for MSME profit reports.
+- Onboard MSME (tile 6) shows the Walrus upload flow — immutable audit trail for legal documents.</a:t>
             </a:r>
             <a:endParaRPr lang="en-US" dirty="0"/>
           </a:p>
@@ -877,11 +877,11 @@
           <a:p>
             <a:r>
               <a:rPr lang="en-US" dirty="0"/>
-              <a:t>- Tekankan setiap fitur Sui menyelesaikan masalah konkret — bukan checklist fitur.
-- PTB bulk distribution adalah killer feature: 152 investor atomik, tidak bisa di EVM tanpa loop tx.
-- Walrus = trust layer: dokumen legal immutable, bukti untuk DAO jury.
-- DeepBook memberi likuiditas sekunder tanpa exit window — beda dari crowdfund biasa.
-- zkLogin + sponsored tx = zero-friction onboarding untuk investor pemula Indonesia.</a:t>
+              <a:t>- Emphasize every Sui feature solves a concrete problem — not a feature checklist.
+- PTB bulk distribution is the killer feature: 152 atomic investors, impossible on EVM without tx loops.
+- Walrus = trust layer: immutable legal documents, proof for DAO jury.
+- DeepBook provides secondary liquidity without exit window — different from typical crowdfunding.
+- zkLogin + sponsored tx = zero-friction onboarding for Indonesian first-time investors.</a:t>
             </a:r>
             <a:endParaRPr lang="en-US" dirty="0"/>
           </a:p>
@@ -969,11 +969,11 @@
           <a:p>
             <a:r>
               <a:rPr lang="en-US" dirty="0"/>
-              <a:t>- Anchor pembuka: Indonesia rank 7 adopsi crypto global — tapi RWA masih &lt; 0.1%.
-- Jelaskan funnel TAM ($16T) → SAM (Rp 1.2Q funding gap UMKM) → SOM (Rp 50M dari 500 UMKM year 1-2).
-- Traction demo: 6 UMKM live, 8 Sui features aktif — bukan slide ware.
-- Highlight comparison gas: 0.03 SUI vs $4-12 di Ethereum L1 — biaya distribusi profit jadi viable.
-- ~800ms finality untuk 152 investor atomik — tunjukkan PTB itu bukan teori.</a:t>
+              <a:t>- Opening anchor: Indonesia ranks 7 globally in crypto adoption — but RWA is still &lt; 0.1%.
+- Explain the funnel TAM ($16T) → SAM (Rp 1.2Q MSME funding gap) → SOM (Rp 50M from 500 MSMEs year 1-2).
+- Demo traction: 6 MSMEs live, 8 active Sui features — not slide ware.
+- Highlight gas comparison: 0.03 SUI vs $4-12 on Ethereum L1 — profit distribution cost becomes viable.
+- ~800ms finality for 152 atomic investors — show that PTB is not theory.</a:t>
             </a:r>
             <a:endParaRPr lang="en-US" dirty="0"/>
           </a:p>
@@ -1061,11 +1061,11 @@
           <a:p>
             <a:r>
               <a:rPr lang="en-US" dirty="0"/>
-              <a:t>- Tekankan MVP sudah substantial: 5 alur lengkap, bukan slide demo.
-- Q4 2025 publish ke testnet — kontrak Move siap, dapp-kit integration sudah di code.
-- Q1 2026 mainnet dengan DAO jury + DeepBook live — model distribusi profit terbukti.
-- SuiStream SDK open-source di Q2 2026 akan tarik ecosystem builder lain.
-- Cost ke mainnet &lt; $50K (gas + audit) — angka realistis untuk bootstrap.</a:t>
+              <a:t>- Emphasize the MVP is substantial: 5 complete flows, not a demo slide.
+- Q4 2025 publish to testnet — Move contracts ready, dapp-kit integration already in code.
+- Q1 2026 mainnet with DAO jury + DeepBook live — proven profit distribution model.
+- SuiStream open-source SDK in Q2 2026 will attract other ecosystem builders.
+- Cost to mainnet &lt; $50K (gas + audit) — realistic bootstrap figure.</a:t>
             </a:r>
             <a:endParaRPr lang="en-US" dirty="0"/>
           </a:p>
@@ -1153,11 +1153,11 @@
           <a:p>
             <a:r>
               <a:rPr lang="en-US" dirty="0"/>
-              <a:t>- Tutup dengan ask pertama: menang = grant untuk audit + mainnet deployment.
-- Ask kedua: minta intro ke koperasi UMKM — pipeline 100+ pilot.
-- Ask ketiga: feedback Sui core team untuk SuiStream SDK open-source.
-- Tunjukkan live demo URL: preview-link.space-z.ai — ajak juri coba langsung.
-- Penutup: terima kasih, tim based in Indonesia, building for 280M population.</a:t>
+              <a:t>- Close with the first ask: winning = grant for audit + mainnet deployment.
+- Second ask: request intro to MSME cooperatives — pipeline of 100+ pilots.
+- Third ask: feedback from Sui core team for open-source SuiStream SDK.
+- Show the live demo URL: preview-link.space-z.ai — invite jury to try it directly.
+- Closing: thank you, team based in Indonesia, building for 280M population.</a:t>
             </a:r>
             <a:endParaRPr lang="en-US" dirty="0"/>
           </a:p>
@@ -1797,7 +1797,7 @@
         </p:blipFill>
         <p:spPr>
           <a:xfrm>
-            <a:off x="514350" y="1045555"/>
+            <a:off x="514350" y="790501"/>
             <a:ext cx="257175" cy="257175"/>
           </a:xfrm>
           <a:prstGeom prst="rect">
@@ -1813,7 +1813,7 @@
         </p:nvSpPr>
         <p:spPr>
           <a:xfrm>
-            <a:off x="539353" y="1070558"/>
+            <a:off x="539353" y="815504"/>
             <a:ext cx="207169" cy="207169"/>
           </a:xfrm>
           <a:prstGeom prst="rect">
@@ -1852,7 +1852,7 @@
         </p:nvSpPr>
         <p:spPr>
           <a:xfrm>
-            <a:off x="857250" y="1077702"/>
+            <a:off x="857250" y="822647"/>
             <a:ext cx="831770" cy="208312"/>
           </a:xfrm>
           <a:prstGeom prst="rect">
@@ -1894,7 +1894,7 @@
         </p:nvSpPr>
         <p:spPr>
           <a:xfrm>
-            <a:off x="1524633" y="1159855"/>
+            <a:off x="1524633" y="904801"/>
             <a:ext cx="28575" cy="28575"/>
           </a:xfrm>
           <a:prstGeom prst="ellipse">
@@ -1926,7 +1926,7 @@
         </p:nvSpPr>
         <p:spPr>
           <a:xfrm>
-            <a:off x="1638933" y="1115206"/>
+            <a:off x="1638933" y="860152"/>
             <a:ext cx="5161917" cy="164592"/>
           </a:xfrm>
           <a:prstGeom prst="rect">
@@ -1970,8 +1970,8 @@
         </p:nvSpPr>
         <p:spPr>
           <a:xfrm>
-            <a:off x="514350" y="1502755"/>
-            <a:ext cx="6915150" cy="1101593"/>
+            <a:off x="514350" y="1247701"/>
+            <a:ext cx="6915150" cy="1652390"/>
           </a:xfrm>
           <a:prstGeom prst="rect">
             <a:avLst/>
@@ -1998,7 +1998,7 @@
                 <a:ea typeface="Carlito" pitchFamily="34" charset="-122"/>
                 <a:cs typeface="Carlito" pitchFamily="34" charset="-120"/>
               </a:rPr>
-              <a:t>Investasi UMKM Indonesia.</a:t>
+              <a:t>Invest in Indonesian MSMEs.</a:t>
             </a:r>
             <a:endParaRPr lang="en-US" sz="3825" dirty="0"/>
           </a:p>
@@ -2018,7 +2018,7 @@
                 <a:ea typeface="Carlito" pitchFamily="34" charset="-122"/>
                 <a:cs typeface="Carlito" pitchFamily="34" charset="-120"/>
               </a:rPr>
-              <a:t>Profit mengalir per detik.</a:t>
+              <a:t>Profits flow per second.</a:t>
             </a:r>
             <a:endParaRPr lang="en-US" sz="3825" dirty="0"/>
           </a:p>
@@ -2032,7 +2032,7 @@
         </p:nvSpPr>
         <p:spPr>
           <a:xfrm>
-            <a:off x="514350" y="2722773"/>
+            <a:off x="514350" y="2977716"/>
             <a:ext cx="5143500" cy="763810"/>
           </a:xfrm>
           <a:prstGeom prst="rect">
@@ -2062,7 +2062,7 @@
                 <a:ea typeface="Carlito" pitchFamily="34" charset="-122"/>
                 <a:cs typeface="Carlito" pitchFamily="34" charset="-120"/>
               </a:rPr>
-              <a:t>Marketplace kepemilikan fraksional UMKM dengan distribusi profit via SuiStream primitive di jaringan Sui. Zero platform fee, zero manual transfer, atomic.</a:t>
+              <a:t>Fractional ownership marketplace for MSMEs with profit distribution via SuiStream primitive on the Sui network. Zero platform fee, zero manual transfer, atomic.</a:t>
             </a:r>
             <a:endParaRPr lang="en-US" sz="1238" dirty="0"/>
           </a:p>
@@ -2107,7 +2107,7 @@
         <p:spPr>
           <a:xfrm>
             <a:off x="643607" y="4396978"/>
-            <a:ext cx="4019645" cy="126609"/>
+            <a:ext cx="4144415" cy="126609"/>
           </a:xfrm>
           <a:prstGeom prst="rect">
             <a:avLst/>
@@ -2136,7 +2136,7 @@
                 <a:ea typeface="Courier New" pitchFamily="34" charset="-122"/>
                 <a:cs typeface="Courier New" pitchFamily="34" charset="-120"/>
               </a:rPr>
-              <a:t>UMKM terverifikasi investor/UMKM estimasi APY</a:t>
+              <a:t>verified MSMEs investors per MSME estimated APY</a:t>
             </a:r>
             <a:endParaRPr lang="en-US" sz="800" dirty="0"/>
           </a:p>
@@ -2151,7 +2151,7 @@
         <p:spPr>
           <a:xfrm>
             <a:off x="514350" y="4382691"/>
-            <a:ext cx="1204838" cy="164592"/>
+            <a:ext cx="973782" cy="164592"/>
           </a:xfrm>
           <a:prstGeom prst="rect">
             <a:avLst/>
@@ -2192,7 +2192,7 @@
         </p:nvSpPr>
         <p:spPr>
           <a:xfrm>
-            <a:off x="1754907" y="4382691"/>
+            <a:off x="1523851" y="4382691"/>
             <a:ext cx="93538" cy="164592"/>
           </a:xfrm>
           <a:prstGeom prst="rect">
@@ -2236,8 +2236,8 @@
         </p:nvSpPr>
         <p:spPr>
           <a:xfrm>
-            <a:off x="1884164" y="4382691"/>
-            <a:ext cx="1204950" cy="164592"/>
+            <a:off x="1653108" y="4382691"/>
+            <a:ext cx="1493713" cy="164592"/>
           </a:xfrm>
           <a:prstGeom prst="rect">
             <a:avLst/>
@@ -2278,7 +2278,7 @@
         </p:nvSpPr>
         <p:spPr>
           <a:xfrm>
-            <a:off x="3124833" y="4382691"/>
+            <a:off x="3182541" y="4382691"/>
             <a:ext cx="93538" cy="164592"/>
           </a:xfrm>
           <a:prstGeom prst="rect">
@@ -2322,8 +2322,8 @@
         </p:nvSpPr>
         <p:spPr>
           <a:xfrm>
-            <a:off x="3254090" y="4382691"/>
-            <a:ext cx="1111411" cy="164592"/>
+            <a:off x="3311798" y="4382691"/>
+            <a:ext cx="1169231" cy="164592"/>
           </a:xfrm>
           <a:prstGeom prst="rect">
             <a:avLst/>
@@ -2365,7 +2365,7 @@
         <p:spPr>
           <a:xfrm>
             <a:off x="514350" y="4579144"/>
-            <a:ext cx="4159243" cy="164592"/>
+            <a:ext cx="4284013" cy="164592"/>
           </a:xfrm>
           <a:prstGeom prst="rect">
             <a:avLst/>
@@ -2402,7 +2402,7 @@
       </p:sp>
       <p:pic>
         <p:nvPicPr>
-          <p:cNvPr id="24" name="Image 3" descr="/tmp/h2p-svg-1781828584948-1vjy83.png">    </p:cNvPr>
+          <p:cNvPr id="24" name="Image 3" descr="/tmp/h2p-svg-1781977821166-smjmyv.png">    </p:cNvPr>
           <p:cNvPicPr>
             <a:picLocks noChangeAspect="1"/>
           </p:cNvPicPr>
@@ -2624,7 +2624,7 @@
                 <a:ea typeface="Carlito" pitchFamily="34" charset="-122"/>
                 <a:cs typeface="Carlito" pitchFamily="34" charset="-120"/>
               </a:rPr>
-              <a:t>MASALAH</a:t>
+              <a:t>PROBLEM</a:t>
             </a:r>
             <a:endParaRPr lang="en-US" sz="800" dirty="0"/>
           </a:p>
@@ -2711,7 +2711,7 @@
         <p:spPr>
           <a:xfrm>
             <a:off x="457200" y="689372"/>
-            <a:ext cx="4771355" cy="760193"/>
+            <a:ext cx="4771355" cy="1140290"/>
           </a:xfrm>
           <a:prstGeom prst="rect">
             <a:avLst/>
@@ -2738,7 +2738,7 @@
                 <a:ea typeface="Carlito" pitchFamily="34" charset="-122"/>
                 <a:cs typeface="Carlito" pitchFamily="34" charset="-120"/>
               </a:rPr>
-              <a:t>UMKM Indonesia raksasa,</a:t>
+              <a:t>Indonesia's MSMEs are massive,</a:t>
             </a:r>
             <a:endParaRPr lang="en-US" sz="2475" dirty="0"/>
           </a:p>
@@ -2758,7 +2758,7 @@
                 <a:ea typeface="Carlito" pitchFamily="34" charset="-122"/>
                 <a:cs typeface="Carlito" pitchFamily="34" charset="-120"/>
               </a:rPr>
-              <a:t>tapi investor tak punya akses.</a:t>
+              <a:t>but investors have no access.</a:t>
             </a:r>
             <a:endParaRPr lang="en-US" sz="2475" dirty="0"/>
           </a:p>
@@ -2772,7 +2772,7 @@
         </p:nvSpPr>
         <p:spPr>
           <a:xfrm>
-            <a:off x="457200" y="1521842"/>
+            <a:off x="457200" y="1873783"/>
             <a:ext cx="342900" cy="21431"/>
           </a:xfrm>
           <a:prstGeom prst="roundRect">
@@ -2804,8 +2804,8 @@
         </p:nvSpPr>
         <p:spPr>
           <a:xfrm>
-            <a:off x="457200" y="1671861"/>
-            <a:ext cx="3429000" cy="839033"/>
+            <a:off x="457200" y="2023802"/>
+            <a:ext cx="3429000" cy="1048792"/>
           </a:xfrm>
           <a:prstGeom prst="rect">
             <a:avLst/>
@@ -2832,7 +2832,7 @@
                 <a:ea typeface="Carlito" pitchFamily="34" charset="-122"/>
                 <a:cs typeface="Carlito" pitchFamily="34" charset="-120"/>
               </a:rPr>
-              <a:t>64 juta UMKM menyumbang 60% PDB Indonesia, tapi 9 dari 10 tidak bisa akses pinjaman bank. Investor retail juga tidak punya jalur investasi kecil ke bisnis lokal — minimum Rp 100 juta di sekuritas, no fractional ownership, no real-time profit.</a:t>
+              <a:t>64 million MSMEs contribute 60% of Indonesia's GDP, but 9 out of 10 cannot access bank loans. Retail investors also have no small-ticket investment channel to local businesses — minimum Rp 100 million at securities firms, no fractional ownership, no real-time profit.</a:t>
             </a:r>
             <a:endParaRPr lang="en-US" sz="956" dirty="0"/>
           </a:p>
@@ -2846,7 +2846,7 @@
         </p:nvSpPr>
         <p:spPr>
           <a:xfrm>
-            <a:off x="457200" y="2605906"/>
+            <a:off x="457200" y="3152068"/>
             <a:ext cx="4337596" cy="705195"/>
           </a:xfrm>
           <a:prstGeom prst="rect">
@@ -2878,7 +2878,7 @@
                 <a:ea typeface="Carlito" pitchFamily="34" charset="-122"/>
                 <a:cs typeface="Carlito" pitchFamily="34" charset="-120"/>
               </a:rPr>
-              <a:t>Pinjaman bank butuh agunan &amp; 6-12 bulan proses — 87% UMKM ditolak</a:t>
+              <a:t>Bank loans require collateral &amp; 6-12 month process — 87% of MSMEs rejected</a:t>
             </a:r>
             <a:endParaRPr lang="en-US" sz="800" dirty="0"/>
           </a:p>
@@ -2902,7 +2902,7 @@
                 <a:ea typeface="Carlito" pitchFamily="34" charset="-122"/>
                 <a:cs typeface="Carlito" pitchFamily="34" charset="-120"/>
               </a:rPr>
-              <a:t>Saham publik butuh Rp 100jt min — barrier terlalu tinggi untuk Gen Z &amp; milenial</a:t>
+              <a:t>Public stocks require Rp 100M min — barrier too high for Gen Z &amp; millennials</a:t>
             </a:r>
             <a:endParaRPr lang="en-US" sz="800" dirty="0"/>
           </a:p>
@@ -2926,7 +2926,7 @@
                 <a:ea typeface="Carlito" pitchFamily="34" charset="-122"/>
                 <a:cs typeface="Carlito" pitchFamily="34" charset="-120"/>
               </a:rPr>
-              <a:t>Crowdfunding konvensional pakai platform fee 10-20% &amp; manual transfer bulanan</a:t>
+              <a:t>Conventional crowdfunding charges platform fee 10-20% &amp; monthly manual transfers</a:t>
             </a:r>
             <a:endParaRPr lang="en-US" sz="800" dirty="0"/>
           </a:p>
@@ -3007,7 +3007,7 @@
                 <a:ea typeface="Courier New" pitchFamily="34" charset="-122"/>
                 <a:cs typeface="Courier New" pitchFamily="34" charset="-120"/>
               </a:rPr>
-              <a:t>Funding gap Indonesia tumbuh 8.4% YoY · sektor informal terabaikan</a:t>
+              <a:t>Indonesia's funding gap grows 8.4% YoY · informal sector neglected</a:t>
             </a:r>
             <a:endParaRPr lang="en-US" sz="800" dirty="0"/>
           </a:p>
@@ -3137,7 +3137,7 @@
                 <a:ea typeface="Carlito" pitchFamily="34" charset="-122"/>
                 <a:cs typeface="Carlito" pitchFamily="34" charset="-120"/>
               </a:rPr>
-              <a:t>UMKM aktif di Indonesia</a:t>
+              <a:t>Active MSMEs in Indonesia</a:t>
             </a:r>
             <a:endParaRPr lang="en-US" sz="800" dirty="0"/>
           </a:p>
@@ -3179,7 +3179,7 @@
                 <a:ea typeface="Liberation Sans Narrow" pitchFamily="34" charset="-122"/>
                 <a:cs typeface="Liberation Sans Narrow" pitchFamily="34" charset="-120"/>
               </a:rPr>
-              <a:t>sumber: Kemenkop UKM 2024</a:t>
+              <a:t>source: Kemenkop UKM 2024</a:t>
             </a:r>
             <a:endParaRPr lang="en-US" sz="800" dirty="0"/>
           </a:p>
@@ -3351,16 +3351,16 @@
         <p:spPr>
           <a:xfrm>
             <a:off x="5287714" y="2217353"/>
-            <a:ext cx="2991468" cy="114662"/>
-          </a:xfrm>
-          <a:prstGeom prst="rect">
-            <a:avLst/>
-          </a:prstGeom>
-          <a:noFill/>
-          <a:ln/>
-        </p:spPr>
-        <p:txBody>
-          <a:bodyPr wrap="none" lIns="0" tIns="0" rIns="0" bIns="0" rtlCol="0" anchor="t">
+            <a:ext cx="3076938" cy="114662"/>
+          </a:xfrm>
+          <a:prstGeom prst="rect">
+            <a:avLst/>
+          </a:prstGeom>
+          <a:noFill/>
+          <a:ln/>
+        </p:spPr>
+        <p:txBody>
+          <a:bodyPr wrap="square" lIns="0" tIns="0" rIns="0" bIns="0" rtlCol="0" anchor="t">
             <a:normAutofit/>
           </a:bodyPr>
           <a:lstStyle/>
@@ -3380,7 +3380,7 @@
                 <a:ea typeface="Carlito" pitchFamily="34" charset="-122"/>
                 <a:cs typeface="Carlito" pitchFamily="34" charset="-120"/>
               </a:rPr>
-              <a:t>kontribusi PDB Indonesia</a:t>
+              <a:t>contribution to Indonesia's GDP</a:t>
             </a:r>
             <a:endParaRPr lang="en-US" sz="800" dirty="0"/>
           </a:p>
@@ -3422,7 +3422,7 @@
                 <a:ea typeface="Liberation Sans Narrow" pitchFamily="34" charset="-122"/>
                 <a:cs typeface="Liberation Sans Narrow" pitchFamily="34" charset="-120"/>
               </a:rPr>
-              <a:t>tapi akses kredit &lt; 12%</a:t>
+              <a:t>but credit access &lt; 12%</a:t>
             </a:r>
             <a:endParaRPr lang="en-US" sz="800" dirty="0"/>
           </a:p>
@@ -3623,7 +3623,7 @@
                 <a:ea typeface="Carlito" pitchFamily="34" charset="-122"/>
                 <a:cs typeface="Carlito" pitchFamily="34" charset="-120"/>
               </a:rPr>
-              <a:t>funding gap tahunan</a:t>
+              <a:t>annual funding gap</a:t>
             </a:r>
             <a:endParaRPr lang="en-US" sz="800" dirty="0"/>
           </a:p>
@@ -3665,7 +3665,7 @@
                 <a:ea typeface="Courier New" pitchFamily="34" charset="-122"/>
                 <a:cs typeface="Courier New" pitchFamily="34" charset="-120"/>
               </a:rPr>
-              <a:t>sektor informal Indonesia</a:t>
+              <a:t>Indonesia's informal sector</a:t>
             </a:r>
             <a:endParaRPr lang="en-US" sz="800" dirty="0"/>
           </a:p>
@@ -3938,7 +3938,7 @@
                 <a:ea typeface="Carlito" pitchFamily="34" charset="-122"/>
                 <a:cs typeface="Carlito" pitchFamily="34" charset="-120"/>
               </a:rPr>
-              <a:t>SOLUSI</a:t>
+              <a:t>SOLUTION</a:t>
             </a:r>
             <a:endParaRPr lang="en-US" sz="800" dirty="0"/>
           </a:p>
@@ -3980,7 +3980,7 @@
                 <a:ea typeface="Carlito" pitchFamily="34" charset="-122"/>
                 <a:cs typeface="Carlito" pitchFamily="34" charset="-120"/>
               </a:rPr>
-              <a:t>Dua lapisan, satu pengalaman: </a:t>
+              <a:t>Two layers, one experience: </a:t>
             </a:r>
             <a:pPr algn="l" indent="0" marL="0">
               <a:lnSpc>
@@ -4031,7 +4031,7 @@
                 <a:ea typeface="Carlito" pitchFamily="34" charset="-122"/>
                 <a:cs typeface="Carlito" pitchFamily="34" charset="-120"/>
               </a:rPr>
-              <a:t>aplikasi</a:t>
+              <a:t>app</a:t>
             </a:r>
             <a:pPr algn="l" indent="0" marL="0">
               <a:lnSpc>
@@ -4090,7 +4090,7 @@
                 <a:ea typeface="Carlito" pitchFamily="34" charset="-122"/>
                 <a:cs typeface="Carlito" pitchFamily="34" charset="-120"/>
               </a:rPr>
-              <a:t>Arthavest adalah aplikasi yang dibangun di atas SuiStream — primitive money-stream yang composable. Profit bulanan UMKM dikonversi menjadi stream object yang mengalir ke wallet investor setiap detik.</a:t>
+              <a:t>Arthavest is an app built on top of SuiStream — a composable money-stream primitive. Monthly MSME profits are converted into stream objects that flow to investor wallets every second.</a:t>
             </a:r>
             <a:endParaRPr lang="en-US" sz="844" dirty="0"/>
           </a:p>
@@ -4495,7 +4495,7 @@
                 <a:ea typeface="Carlito" pitchFamily="34" charset="-122"/>
                 <a:cs typeface="Carlito" pitchFamily="34" charset="-120"/>
               </a:rPr>
-              <a:t>Money stream sebagai object Move — composable, transferable, fractionalizable</a:t>
+              <a:t>Money stream as a Move object — composable, transferable, fractionalizable</a:t>
             </a:r>
             <a:endParaRPr lang="en-US" sz="800" dirty="0"/>
           </a:p>
@@ -4510,7 +4510,7 @@
         <p:spPr>
           <a:xfrm>
             <a:off x="620078" y="2437818"/>
-            <a:ext cx="855754" cy="206026"/>
+            <a:ext cx="928085" cy="206026"/>
           </a:xfrm>
           <a:prstGeom prst="roundRect">
             <a:avLst>
@@ -4542,7 +4542,7 @@
         <p:spPr>
           <a:xfrm>
             <a:off x="850106" y="2491718"/>
-            <a:ext cx="517141" cy="91440"/>
+            <a:ext cx="589471" cy="91440"/>
           </a:xfrm>
           <a:prstGeom prst="rect">
             <a:avLst/>
@@ -4569,7 +4569,7 @@
                 <a:ea typeface="Carlito" pitchFamily="34" charset="-122"/>
                 <a:cs typeface="Carlito" pitchFamily="34" charset="-120"/>
               </a:rPr>
-              <a:t>Rate per detik</a:t>
+              <a:t>Per-second rate</a:t>
             </a:r>
             <a:endParaRPr lang="en-US" sz="800" dirty="0"/>
           </a:p>
@@ -4622,7 +4622,7 @@
         </p:nvSpPr>
         <p:spPr>
           <a:xfrm>
-            <a:off x="1472974" y="2437818"/>
+            <a:off x="1545305" y="2437818"/>
             <a:ext cx="865465" cy="206026"/>
           </a:xfrm>
           <a:prstGeom prst="roundRect">
@@ -4654,7 +4654,7 @@
         </p:nvSpPr>
         <p:spPr>
           <a:xfrm>
-            <a:off x="1703003" y="2491718"/>
+            <a:off x="1775333" y="2491718"/>
             <a:ext cx="526852" cy="91440"/>
           </a:xfrm>
           <a:prstGeom prst="rect">
@@ -4696,7 +4696,7 @@
         </p:nvSpPr>
         <p:spPr>
           <a:xfrm>
-            <a:off x="1581559" y="2501540"/>
+            <a:off x="1653890" y="2501540"/>
             <a:ext cx="91440" cy="91440"/>
           </a:xfrm>
           <a:prstGeom prst="rect">
@@ -4735,7 +4735,7 @@
         </p:nvSpPr>
         <p:spPr>
           <a:xfrm>
-            <a:off x="2335582" y="2437818"/>
+            <a:off x="2407913" y="2437818"/>
             <a:ext cx="802734" cy="206026"/>
           </a:xfrm>
           <a:prstGeom prst="roundRect">
@@ -4767,7 +4767,7 @@
         </p:nvSpPr>
         <p:spPr>
           <a:xfrm>
-            <a:off x="2565611" y="2491718"/>
+            <a:off x="2637941" y="2491718"/>
             <a:ext cx="464121" cy="91440"/>
           </a:xfrm>
           <a:prstGeom prst="rect">
@@ -4809,7 +4809,7 @@
         </p:nvSpPr>
         <p:spPr>
           <a:xfrm>
-            <a:off x="2444167" y="2501540"/>
+            <a:off x="2516498" y="2501540"/>
             <a:ext cx="91440" cy="91440"/>
           </a:xfrm>
           <a:prstGeom prst="rect">
@@ -4848,7 +4848,7 @@
         </p:nvSpPr>
         <p:spPr>
           <a:xfrm>
-            <a:off x="3135459" y="2437818"/>
+            <a:off x="3207789" y="2437818"/>
             <a:ext cx="772038" cy="206026"/>
           </a:xfrm>
           <a:prstGeom prst="roundRect">
@@ -4880,7 +4880,7 @@
         </p:nvSpPr>
         <p:spPr>
           <a:xfrm>
-            <a:off x="3365488" y="2491718"/>
+            <a:off x="3437818" y="2491718"/>
             <a:ext cx="433425" cy="91440"/>
           </a:xfrm>
           <a:prstGeom prst="rect">
@@ -4922,7 +4922,7 @@
         </p:nvSpPr>
         <p:spPr>
           <a:xfrm>
-            <a:off x="3244044" y="2501540"/>
+            <a:off x="3316374" y="2501540"/>
             <a:ext cx="91440" cy="91440"/>
           </a:xfrm>
           <a:prstGeom prst="rect">
@@ -5243,7 +5243,7 @@
         <p:spPr>
           <a:xfrm>
             <a:off x="4820603" y="1594534"/>
-            <a:ext cx="1125208" cy="212027"/>
+            <a:ext cx="912235" cy="212027"/>
           </a:xfrm>
           <a:prstGeom prst="roundRect">
             <a:avLst>
@@ -5275,7 +5275,7 @@
         <p:spPr>
           <a:xfrm>
             <a:off x="5050631" y="1655899"/>
-            <a:ext cx="786594" cy="91440"/>
+            <a:ext cx="573621" cy="91440"/>
           </a:xfrm>
           <a:prstGeom prst="rect">
             <a:avLst/>
@@ -5302,7 +5302,7 @@
                 <a:ea typeface="Liberation Sans Narrow" pitchFamily="34" charset="-122"/>
                 <a:cs typeface="Liberation Sans Narrow" pitchFamily="34" charset="-120"/>
               </a:rPr>
-              <a:t>LAYER 2 · APLIKASI</a:t>
+              <a:t>LAYER 2 · APP</a:t>
             </a:r>
             <a:endParaRPr lang="en-US" sz="800" dirty="0"/>
           </a:p>
@@ -5509,7 +5509,7 @@
                 <a:ea typeface="Carlito" pitchFamily="34" charset="-122"/>
                 <a:cs typeface="Carlito" pitchFamily="34" charset="-120"/>
               </a:rPr>
-              <a:t>Marketplace UMKM + distribusi profit via SuiStream</a:t>
+              <a:t>MSME marketplace + profit distribution via SuiStream</a:t>
             </a:r>
             <a:endParaRPr lang="en-US" sz="800" dirty="0"/>
           </a:p>
@@ -5556,7 +5556,7 @@
                 <a:ea typeface="Carlito" pitchFamily="34" charset="-122"/>
                 <a:cs typeface="Carlito" pitchFamily="34" charset="-120"/>
               </a:rPr>
-              <a:t>1 UMKM onboard (mint NFT + share tokens)</a:t>
+              <a:t>1 MSME onboard (mint NFT + share tokens)</a:t>
             </a:r>
             <a:endParaRPr lang="en-US" sz="800" dirty="0"/>
           </a:p>
@@ -5581,7 +5581,7 @@
                 <a:ea typeface="Carlito" pitchFamily="34" charset="-122"/>
                 <a:cs typeface="Carlito" pitchFamily="34" charset="-120"/>
               </a:rPr>
-              <a:t>2 Investor beli share (PTB atomic)</a:t>
+              <a:t>2 Investor buys shares (PTB atomic)</a:t>
             </a:r>
             <a:endParaRPr lang="en-US" sz="800" dirty="0"/>
           </a:p>
@@ -5606,7 +5606,7 @@
                 <a:ea typeface="Carlito" pitchFamily="34" charset="-122"/>
                 <a:cs typeface="Carlito" pitchFamily="34" charset="-120"/>
               </a:rPr>
-              <a:t>3 Owner lapork profit (Walrus proof)</a:t>
+              <a:t>3 Owner reports profit (Walrus proof)</a:t>
             </a:r>
             <a:endParaRPr lang="en-US" sz="800" dirty="0"/>
           </a:p>
@@ -5631,7 +5631,7 @@
                 <a:ea typeface="Carlito" pitchFamily="34" charset="-122"/>
                 <a:cs typeface="Carlito" pitchFamily="34" charset="-120"/>
               </a:rPr>
-              <a:t>4 Distribusi otomatis (PTB bulk create_stream)</a:t>
+              <a:t>4 Automatic distribution (PTB bulk create_stream)</a:t>
             </a:r>
             <a:endParaRPr lang="en-US" sz="800" dirty="0"/>
           </a:p>
@@ -5656,7 +5656,7 @@
                 <a:ea typeface="Carlito" pitchFamily="34" charset="-122"/>
                 <a:cs typeface="Carlito" pitchFamily="34" charset="-120"/>
               </a:rPr>
-              <a:t>5 Investor withdraw (sub-second)</a:t>
+              <a:t>5 Investor withdraws (sub-second)</a:t>
             </a:r>
             <a:endParaRPr lang="en-US" sz="800" dirty="0"/>
           </a:p>
@@ -6113,7 +6113,7 @@
         <p:spPr>
           <a:xfrm>
             <a:off x="400050" y="285750"/>
-            <a:ext cx="6976427" cy="133302"/>
+            <a:ext cx="7125654" cy="133302"/>
           </a:xfrm>
           <a:prstGeom prst="rect">
             <a:avLst/>
@@ -6142,7 +6142,7 @@
                 <a:ea typeface="Carlito" pitchFamily="34" charset="-122"/>
                 <a:cs typeface="Carlito" pitchFamily="34" charset="-120"/>
               </a:rPr>
-              <a:t>DEMO LIVE</a:t>
+              <a:t>LIVE DEMO</a:t>
             </a:r>
             <a:endParaRPr lang="en-US" sz="800" dirty="0"/>
           </a:p>
@@ -6157,7 +6157,7 @@
         <p:spPr>
           <a:xfrm>
             <a:off x="400050" y="446484"/>
-            <a:ext cx="4915681" cy="305476"/>
+            <a:ext cx="5020828" cy="305476"/>
           </a:xfrm>
           <a:prstGeom prst="rect">
             <a:avLst/>
@@ -6184,7 +6184,7 @@
                 <a:ea typeface="Carlito" pitchFamily="34" charset="-122"/>
                 <a:cs typeface="Carlito" pitchFamily="34" charset="-120"/>
               </a:rPr>
-              <a:t>Lima alur utama, satu pengalaman mulus.</a:t>
+              <a:t>Five main flows, one seamless experience.</a:t>
             </a:r>
             <a:endParaRPr lang="en-US" sz="2025" dirty="0"/>
           </a:p>
@@ -6211,7 +6211,7 @@
           <a:effectLst>
             <a:outerShdw sx="100000" sy="100000" kx="0" ky="0" algn="bl" rotWithShape="0" blurRad="101600" dist="50800" dir="16200000">
               <a:srgbClr val="0D9488">
-                <a:alpha val="20000"/>
+                <a:alpha val="14000"/>
               </a:srgbClr>
             </a:outerShdw>
           </a:effectLst>
@@ -6305,7 +6305,7 @@
                 <a:ea typeface="Carlito" pitchFamily="34" charset="-122"/>
                 <a:cs typeface="Carlito" pitchFamily="34" charset="-120"/>
               </a:rPr>
-              <a:t>Setiap alur dibangun dengan Sui-native features: zkLogin untuk onboarding, PTB untuk atomicity, Walrus untuk audit trail. Tidak bisa direplikasi sebersih ini di EVM.</a:t>
+              <a:t>Each flow built with Sui-native features: zkLogin for onboarding, PTB for atomicity, Walrus for audit trail. Cannot be replicated this cleanly on EVM.</a:t>
             </a:r>
             <a:endParaRPr lang="en-US" sz="800" dirty="0"/>
           </a:p>
@@ -6396,7 +6396,7 @@
         <p:spPr>
           <a:xfrm>
             <a:off x="707231" y="1299046"/>
-            <a:ext cx="998025" cy="164592"/>
+            <a:ext cx="985990" cy="164592"/>
           </a:xfrm>
           <a:prstGeom prst="rect">
             <a:avLst/>
@@ -6423,7 +6423,7 @@
                 <a:ea typeface="Carlito" pitchFamily="34" charset="-122"/>
                 <a:cs typeface="Carlito" pitchFamily="34" charset="-120"/>
               </a:rPr>
-              <a:t>Marketplace UMKM</a:t>
+              <a:t>MSME Marketplace</a:t>
             </a:r>
             <a:endParaRPr lang="en-US" sz="800" dirty="0"/>
           </a:p>
@@ -6711,7 +6711,7 @@
                 <a:ea typeface="Liberation Sans Narrow" pitchFamily="34" charset="-122"/>
                 <a:cs typeface="Liberation Sans Narrow" pitchFamily="34" charset="-120"/>
               </a:rPr>
-              <a:t>64% funded · 152 investor</a:t>
+              <a:t>64% funded · 152 investors</a:t>
             </a:r>
             <a:endParaRPr lang="en-US" sz="800" dirty="0"/>
           </a:p>
@@ -6942,7 +6942,7 @@
                 <a:ea typeface="Liberation Sans Narrow" pitchFamily="34" charset="-122"/>
                 <a:cs typeface="Liberation Sans Narrow" pitchFamily="34" charset="-120"/>
               </a:rPr>
-              <a:t>38% funded · 47 investor</a:t>
+              <a:t>38% funded · 47 investors</a:t>
             </a:r>
             <a:endParaRPr lang="en-US" sz="800" dirty="0"/>
           </a:p>
@@ -7102,7 +7102,7 @@
                 <a:ea typeface="Carlito" pitchFamily="34" charset="-122"/>
                 <a:cs typeface="Carlito" pitchFamily="34" charset="-120"/>
               </a:rPr>
-              <a:t>Portfolio Investor</a:t>
+              <a:t>Investor Portfolio</a:t>
             </a:r>
             <a:endParaRPr lang="en-US" sz="800" dirty="0"/>
           </a:p>
@@ -7207,7 +7207,7 @@
       </p:sp>
       <p:pic>
         <p:nvPicPr>
-          <p:cNvPr id="31" name="Image 2" descr="/tmp/h2p-svg-1781828584852-ubmi97.png">    </p:cNvPr>
+          <p:cNvPr id="31" name="Image 2" descr="/tmp/h2p-svg-1781977821126-2sc2qr.png">    </p:cNvPr>
           <p:cNvPicPr>
             <a:picLocks noChangeAspect="1"/>
           </p:cNvPicPr>
@@ -7292,7 +7292,7 @@
           <a:effectLst>
             <a:outerShdw sx="100000" sy="100000" kx="0" ky="0" algn="bl" rotWithShape="0" blurRad="101600" dist="50800" dir="16200000">
               <a:srgbClr val="0D9488">
-                <a:alpha val="20000"/>
+                <a:alpha val="14000"/>
               </a:srgbClr>
             </a:outerShdw>
           </a:effectLst>
@@ -7333,7 +7333,7 @@
       </p:sp>
       <p:pic>
         <p:nvPicPr>
-          <p:cNvPr id="35" name="Image 3" descr="/tmp/h2p-svg-1781828584854-0ul2uv.png">    </p:cNvPr>
+          <p:cNvPr id="35" name="Image 3" descr="/tmp/h2p-svg-1781977821129-6aq424.png">    </p:cNvPr>
           <p:cNvPicPr>
             <a:picLocks noChangeAspect="1"/>
           </p:cNvPicPr>
@@ -7418,7 +7418,7 @@
           <a:effectLst>
             <a:outerShdw sx="100000" sy="100000" kx="0" ky="0" algn="bl" rotWithShape="0" blurRad="101600" dist="50800" dir="16200000">
               <a:srgbClr val="0D9488">
-                <a:alpha val="20000"/>
+                <a:alpha val="14000"/>
               </a:srgbClr>
             </a:outerShdw>
           </a:effectLst>
@@ -7436,7 +7436,7 @@
       </p:sp>
       <p:pic>
         <p:nvPicPr>
-          <p:cNvPr id="38" name="Image 4" descr="/tmp/h2p-svg-1781828584854-foskiu.png">    </p:cNvPr>
+          <p:cNvPr id="38" name="Image 4" descr="/tmp/h2p-svg-1781977821129-2kx9gq.png">    </p:cNvPr>
           <p:cNvPicPr>
             <a:picLocks noChangeAspect="1"/>
           </p:cNvPicPr>
@@ -7521,7 +7521,7 @@
           <a:effectLst>
             <a:outerShdw sx="100000" sy="100000" kx="0" ky="0" algn="bl" rotWithShape="0" blurRad="101600" dist="50800" dir="16200000">
               <a:srgbClr val="0D9488">
-                <a:alpha val="20000"/>
+                <a:alpha val="14000"/>
               </a:srgbClr>
             </a:outerShdw>
           </a:effectLst>
@@ -7605,7 +7605,7 @@
                 <a:ea typeface="Courier New" pitchFamily="34" charset="-122"/>
                 <a:cs typeface="Courier New" pitchFamily="34" charset="-120"/>
               </a:rPr>
-              <a:t>Total aktif</a:t>
+              <a:t>Total active</a:t>
             </a:r>
             <a:endParaRPr lang="en-US" sz="800" dirty="0"/>
           </a:p>
@@ -7780,7 +7780,7 @@
         <p:spPr>
           <a:xfrm>
             <a:off x="6326907" y="1299046"/>
-            <a:ext cx="937325" cy="164592"/>
+            <a:ext cx="925289" cy="164592"/>
           </a:xfrm>
           <a:prstGeom prst="rect">
             <a:avLst/>
@@ -7807,7 +7807,7 @@
                 <a:ea typeface="Carlito" pitchFamily="34" charset="-122"/>
                 <a:cs typeface="Carlito" pitchFamily="34" charset="-120"/>
               </a:rPr>
-              <a:t>Dashboard UMKM</a:t>
+              <a:t>MSME Dashboard</a:t>
             </a:r>
             <a:endParaRPr lang="en-US" sz="800" dirty="0"/>
           </a:p>
@@ -7928,7 +7928,7 @@
         <p:spPr>
           <a:xfrm>
             <a:off x="6191176" y="1561579"/>
-            <a:ext cx="1876685" cy="164592"/>
+            <a:ext cx="1835832" cy="164592"/>
           </a:xfrm>
           <a:prstGeom prst="rect">
             <a:avLst/>
@@ -7969,8 +7969,8 @@
         </p:nvSpPr>
         <p:spPr>
           <a:xfrm>
-            <a:off x="8082149" y="1569616"/>
-            <a:ext cx="490351" cy="164592"/>
+            <a:off x="8041295" y="1569616"/>
+            <a:ext cx="531205" cy="164592"/>
           </a:xfrm>
           <a:prstGeom prst="rect">
             <a:avLst/>
@@ -7997,7 +7997,7 @@
                 <a:ea typeface="Liberation Sans Narrow" pitchFamily="34" charset="-122"/>
                 <a:cs typeface="Liberation Sans Narrow" pitchFamily="34" charset="-120"/>
               </a:rPr>
-              <a:t>152 investor</a:t>
+              <a:t>152 investors</a:t>
             </a:r>
             <a:endParaRPr lang="en-US" sz="800" dirty="0"/>
           </a:p>
@@ -8044,7 +8044,7 @@
         <p:spPr>
           <a:xfrm>
             <a:off x="6191176" y="2036638"/>
-            <a:ext cx="1917539" cy="164592"/>
+            <a:ext cx="1876685" cy="164592"/>
           </a:xfrm>
           <a:prstGeom prst="rect">
             <a:avLst/>
@@ -8102,8 +8102,8 @@
         </p:nvSpPr>
         <p:spPr>
           <a:xfrm>
-            <a:off x="8123002" y="2044675"/>
-            <a:ext cx="449498" cy="164592"/>
+            <a:off x="8082149" y="2044675"/>
+            <a:ext cx="490351" cy="164592"/>
           </a:xfrm>
           <a:prstGeom prst="rect">
             <a:avLst/>
@@ -8130,7 +8130,7 @@
                 <a:ea typeface="Liberation Sans Narrow" pitchFamily="34" charset="-122"/>
                 <a:cs typeface="Liberation Sans Narrow" pitchFamily="34" charset="-120"/>
               </a:rPr>
-              <a:t>47 investor</a:t>
+              <a:t>47 investors</a:t>
             </a:r>
             <a:endParaRPr lang="en-US" sz="800" dirty="0"/>
           </a:p>
@@ -8263,7 +8263,7 @@
         <p:spPr>
           <a:xfrm>
             <a:off x="707231" y="3011425"/>
-            <a:ext cx="822857" cy="164592"/>
+            <a:ext cx="937717" cy="164592"/>
           </a:xfrm>
           <a:prstGeom prst="rect">
             <a:avLst/>
@@ -8290,7 +8290,7 @@
                 <a:ea typeface="Carlito" pitchFamily="34" charset="-122"/>
                 <a:cs typeface="Carlito" pitchFamily="34" charset="-120"/>
               </a:rPr>
-              <a:t>Pasar Sekunder</a:t>
+              <a:t>Secondary Market</a:t>
             </a:r>
             <a:endParaRPr lang="en-US" sz="800" dirty="0"/>
           </a:p>
@@ -9779,7 +9779,7 @@
         <p:spPr>
           <a:xfrm>
             <a:off x="6326907" y="3011425"/>
-            <a:ext cx="822334" cy="164592"/>
+            <a:ext cx="810299" cy="164592"/>
           </a:xfrm>
           <a:prstGeom prst="rect">
             <a:avLst/>
@@ -9806,7 +9806,7 @@
                 <a:ea typeface="Carlito" pitchFamily="34" charset="-122"/>
                 <a:cs typeface="Carlito" pitchFamily="34" charset="-120"/>
               </a:rPr>
-              <a:t>Onboard UMKM</a:t>
+              <a:t>Onboard MSME</a:t>
             </a:r>
             <a:endParaRPr lang="en-US" sz="800" dirty="0"/>
           </a:p>
@@ -9991,7 +9991,7 @@
                 <a:ea typeface="Courier New" pitchFamily="34" charset="-122"/>
                 <a:cs typeface="Courier New" pitchFamily="34" charset="-120"/>
               </a:rPr>
-              <a:t>Akta</a:t>
+              <a:t>Deed</a:t>
             </a:r>
             <a:endParaRPr lang="en-US" sz="800" dirty="0"/>
           </a:p>
@@ -10006,7 +10006,7 @@
         <p:spPr>
           <a:xfrm>
             <a:off x="6278798" y="3334680"/>
-            <a:ext cx="651086" cy="14288"/>
+            <a:ext cx="639700" cy="14288"/>
           </a:xfrm>
           <a:prstGeom prst="rect">
             <a:avLst/>
@@ -10035,7 +10035,7 @@
         </p:nvSpPr>
         <p:spPr>
           <a:xfrm>
-            <a:off x="6920061" y="3223952"/>
+            <a:off x="6908676" y="3223952"/>
             <a:ext cx="128588" cy="128588"/>
           </a:xfrm>
           <a:prstGeom prst="ellipse">
@@ -10065,7 +10065,7 @@
         </p:nvSpPr>
         <p:spPr>
           <a:xfrm>
-            <a:off x="6930777" y="3234668"/>
+            <a:off x="6919392" y="3234668"/>
             <a:ext cx="107156" cy="107156"/>
           </a:xfrm>
           <a:prstGeom prst="rect">
@@ -10104,7 +10104,7 @@
         </p:nvSpPr>
         <p:spPr>
           <a:xfrm>
-            <a:off x="6915596" y="3373971"/>
+            <a:off x="6904211" y="3373971"/>
             <a:ext cx="217454" cy="164592"/>
           </a:xfrm>
           <a:prstGeom prst="rect">
@@ -10146,8 +10146,8 @@
         </p:nvSpPr>
         <p:spPr>
           <a:xfrm>
-            <a:off x="7038938" y="3334680"/>
-            <a:ext cx="651197" cy="14288"/>
+            <a:off x="7027552" y="3334680"/>
+            <a:ext cx="639700" cy="14288"/>
           </a:xfrm>
           <a:prstGeom prst="rect">
             <a:avLst/>
@@ -10176,7 +10176,7 @@
         </p:nvSpPr>
         <p:spPr>
           <a:xfrm>
-            <a:off x="7697614" y="3223952"/>
+            <a:off x="7691921" y="3223952"/>
             <a:ext cx="128588" cy="128588"/>
           </a:xfrm>
           <a:prstGeom prst="ellipse">
@@ -10206,7 +10206,7 @@
         </p:nvSpPr>
         <p:spPr>
           <a:xfrm>
-            <a:off x="7697614" y="3223952"/>
+            <a:off x="7691921" y="3223952"/>
             <a:ext cx="128588" cy="122587"/>
           </a:xfrm>
           <a:prstGeom prst="rect">
@@ -10250,8 +10250,8 @@
         </p:nvSpPr>
         <p:spPr>
           <a:xfrm>
-            <a:off x="7675848" y="3373971"/>
-            <a:ext cx="271949" cy="164592"/>
+            <a:off x="7652965" y="3373971"/>
+            <a:ext cx="264319" cy="164592"/>
           </a:xfrm>
           <a:prstGeom prst="rect">
             <a:avLst/>
@@ -10278,7 +10278,7 @@
                 <a:ea typeface="Courier New" pitchFamily="34" charset="-122"/>
                 <a:cs typeface="Courier New" pitchFamily="34" charset="-120"/>
               </a:rPr>
-              <a:t>Lapor</a:t>
+              <a:t>Report</a:t>
             </a:r>
             <a:endParaRPr lang="en-US" sz="800" dirty="0"/>
           </a:p>
@@ -10292,8 +10292,8 @@
         </p:nvSpPr>
         <p:spPr>
           <a:xfrm>
-            <a:off x="7833680" y="3334680"/>
-            <a:ext cx="651197" cy="14288"/>
+            <a:off x="7845177" y="3334680"/>
+            <a:ext cx="639700" cy="14288"/>
           </a:xfrm>
           <a:prstGeom prst="rect">
             <a:avLst/>
@@ -11045,7 +11045,7 @@
                 <a:ea typeface="Carlito" pitchFamily="34" charset="-122"/>
                 <a:cs typeface="Carlito" pitchFamily="34" charset="-120"/>
               </a:rPr>
-              <a:t>ARSITEKTUR SUI</a:t>
+              <a:t>SUI ARCHITECTURE</a:t>
             </a:r>
             <a:endParaRPr lang="en-US" sz="800" dirty="0"/>
           </a:p>
@@ -11089,7 +11089,7 @@
                 <a:ea typeface="Carlito" pitchFamily="34" charset="-122"/>
                 <a:cs typeface="Carlito" pitchFamily="34" charset="-120"/>
               </a:rPr>
-              <a:t>Enam kekuatan Sui yang dipakai — bukan gimmick, alasan.</a:t>
+              <a:t>Six Sui powers in use — not a gimmick, a reason.</a:t>
             </a:r>
             <a:endParaRPr lang="en-US" sz="2025" dirty="0"/>
           </a:p>
@@ -11131,7 +11131,7 @@
                 <a:ea typeface="Carlito" pitchFamily="34" charset="-122"/>
                 <a:cs typeface="Carlito" pitchFamily="34" charset="-120"/>
               </a:rPr>
-              <a:t>Arthavest tidak mungkin sebersih ini di EVM. Setiap fitur Sui yang dipakai menyelesaikan masalah konkret yang tidak bisa diselesaikan chain lain tanpa trade-off besar.</a:t>
+              <a:t>Arthavest wouldn't be this clean on EVM. Every Sui feature used solves a concrete problem that no other chain can solve without major trade-offs.</a:t>
             </a:r>
             <a:endParaRPr lang="en-US" sz="800" dirty="0"/>
           </a:p>
@@ -11286,7 +11286,7 @@
                 <a:ea typeface="Liberation Sans Narrow" pitchFamily="34" charset="-122"/>
                 <a:cs typeface="Liberation Sans Narrow" pitchFamily="34" charset="-120"/>
               </a:rPr>
-              <a:t>6 / 6 FITUR DIPAKAI</a:t>
+              <a:t>6 / 6 FEATURES USED</a:t>
             </a:r>
             <a:endParaRPr lang="en-US" sz="800" dirty="0"/>
           </a:p>
@@ -11480,7 +11480,7 @@
                 <a:ea typeface="Carlito" pitchFamily="34" charset="-122"/>
                 <a:cs typeface="Carlito" pitchFamily="34" charset="-120"/>
               </a:rPr>
-              <a:t>Setiap UMKM, saham, dan stream adalah object Move punya ID unik. Ownership langsung tanpa registry mapping.</a:t>
+              <a:t>Every MSME, share, and stream is a Move object with a unique ID. Direct ownership without registry mapping.</a:t>
             </a:r>
             <a:endParaRPr lang="en-US" sz="800" dirty="0"/>
           </a:p>
@@ -11559,7 +11559,7 @@
                 <a:ea typeface="Courier New" pitchFamily="34" charset="-122"/>
                 <a:cs typeface="Courier New" pitchFamily="34" charset="-120"/>
               </a:rPr>
-              <a:t>Used in: UMKM NFT · Share token · Stream object</a:t>
+              <a:t>Used in: MSME NFT · Share token · Stream object</a:t>
             </a:r>
             <a:endParaRPr lang="en-US" sz="800" dirty="0"/>
           </a:p>
@@ -11753,7 +11753,7 @@
                 <a:ea typeface="Carlito" pitchFamily="34" charset="-122"/>
                 <a:cs typeface="Carlito" pitchFamily="34" charset="-120"/>
               </a:rPr>
-              <a:t>Distribusi profit ke ratusan investor dieksekusi dalam 1 tx atomik. Tidak ada window partial failure.</a:t>
+              <a:t>Profit distribution to hundreds of investors executes in 1 atomic tx. No partial failure window.</a:t>
             </a:r>
             <a:endParaRPr lang="en-US" sz="800" dirty="0"/>
           </a:p>
@@ -12026,7 +12026,7 @@
                 <a:ea typeface="Carlito" pitchFamily="34" charset="-122"/>
                 <a:cs typeface="Carlito" pitchFamily="34" charset="-120"/>
               </a:rPr>
-              <a:t>Investor pemula login pakai Google/Twitch — tanpa install wallet atau backup seed phrase. Zero-knowledge proof jaga privasi.</a:t>
+              <a:t>New investors log in with Google/Twitch — no wallet install or seed phrase backup. Zero-knowledge proof protects privacy.</a:t>
             </a:r>
             <a:endParaRPr lang="en-US" sz="800" dirty="0"/>
           </a:p>
@@ -12105,7 +12105,7 @@
                 <a:ea typeface="Courier New" pitchFamily="34" charset="-122"/>
                 <a:cs typeface="Courier New" pitchFamily="34" charset="-120"/>
               </a:rPr>
-              <a:t>Used in: Onboarding investor &amp; UMKM</a:t>
+              <a:t>Used in: Investor &amp; MSME onboarding</a:t>
             </a:r>
             <a:endParaRPr lang="en-US" sz="800" dirty="0"/>
           </a:p>
@@ -12299,7 +12299,7 @@
                 <a:ea typeface="Carlito" pitchFamily="34" charset="-122"/>
                 <a:cs typeface="Carlito" pitchFamily="34" charset="-120"/>
               </a:rPr>
-              <a:t>Transaksi pertama investor disponsori platform. User tidak perlu SUI untuk mulai — zero gas barrier.</a:t>
+              <a:t>Investor's first transaction is sponsored by the platform. Users don't need SUI to start — zero gas barrier.</a:t>
             </a:r>
             <a:endParaRPr lang="en-US" sz="800" dirty="0"/>
           </a:p>
@@ -12572,7 +12572,7 @@
                 <a:ea typeface="Carlito" pitchFamily="34" charset="-122"/>
                 <a:cs typeface="Carlito" pitchFamily="34" charset="-120"/>
               </a:rPr>
-              <a:t>Dokumen legal UMKM (Akta, NPWP, laporan keuangan) disimpan permanen di Walrus dengan blob ID on-chain. Immutable audit trail.</a:t>
+              <a:t>MSME legal documents (Akta, NPWP, financial reports) stored permanently on Walrus with on-chain blob ID. Immutable audit trail.</a:t>
             </a:r>
             <a:endParaRPr lang="en-US" sz="800" dirty="0"/>
           </a:p>
@@ -12651,7 +12651,7 @@
                 <a:ea typeface="Courier New" pitchFamily="34" charset="-122"/>
                 <a:cs typeface="Courier New" pitchFamily="34" charset="-120"/>
               </a:rPr>
-              <a:t>Used in: UMKM document verification · DAO jury proof</a:t>
+              <a:t>Used in: MSME document verification · DAO jury proof</a:t>
             </a:r>
             <a:endParaRPr lang="en-US" sz="800" dirty="0"/>
           </a:p>
@@ -12845,7 +12845,7 @@
                 <a:ea typeface="Carlito" pitchFamily="34" charset="-122"/>
                 <a:cs typeface="Carlito" pitchFamily="34" charset="-120"/>
               </a:rPr>
-              <a:t>Saham UMKM yang sudah list bisa dipasar sekunder via DeepBook central limit orderbook. Likuiditas tanpa exit window.</a:t>
+              <a:t>Listed MSME shares can trade on secondary market via DeepBook central limit orderbook. Liquidity without exit window.</a:t>
             </a:r>
             <a:endParaRPr lang="en-US" sz="800" dirty="0"/>
           </a:p>
@@ -13082,7 +13082,7 @@
                 <a:ea typeface="Carlito" pitchFamily="34" charset="-122"/>
                 <a:cs typeface="Carlito" pitchFamily="34" charset="-120"/>
               </a:rPr>
-              <a:t>PASAR &amp; MOMENTUM</a:t>
+              <a:t>MARKET &amp; MOMENTUM</a:t>
             </a:r>
             <a:endParaRPr lang="en-US" sz="800" dirty="0"/>
           </a:p>
@@ -13126,7 +13126,7 @@
                 <a:ea typeface="Carlito" pitchFamily="34" charset="-122"/>
                 <a:cs typeface="Carlito" pitchFamily="34" charset="-120"/>
               </a:rPr>
-              <a:t>RWA + UMKM Indonesia — pasar miliaran dollar yang terabaikan.</a:t>
+              <a:t>RWA + Indonesian MSMEs — a billion-dollar neglected market.</a:t>
             </a:r>
             <a:endParaRPr lang="en-US" sz="1913" dirty="0"/>
           </a:p>
@@ -13168,7 +13168,7 @@
                 <a:ea typeface="Carlito" pitchFamily="34" charset="-122"/>
                 <a:cs typeface="Carlito" pitchFamily="34" charset="-120"/>
               </a:rPr>
-              <a:t>Indonesia punya populasi 280 juta dengan adopsi crypto tinggi (rank 7 global), tapi penetrasi RWA masih &lt; 0.1%. Arthavest adalah jembatan antara UMKM tradisional dan investor crypto-native muda.</a:t>
+              <a:t>Indonesia has 280M population with high crypto adoption (rank 7 globally), but RWA penetration is still &lt; 0.1%. Arthavest is the bridge between traditional MSMEs and young crypto-native investors.</a:t>
             </a:r>
             <a:endParaRPr lang="en-US" sz="800" dirty="0"/>
           </a:p>
@@ -13182,8 +13182,8 @@
         </p:nvSpPr>
         <p:spPr>
           <a:xfrm>
-            <a:off x="7334198" y="417266"/>
-            <a:ext cx="1375462" cy="212027"/>
+            <a:off x="7335649" y="417266"/>
+            <a:ext cx="1374011" cy="212027"/>
           </a:xfrm>
           <a:prstGeom prst="roundRect">
             <a:avLst>
@@ -13214,8 +13214,8 @@
         </p:nvSpPr>
         <p:spPr>
           <a:xfrm>
-            <a:off x="7578514" y="478631"/>
-            <a:ext cx="1022561" cy="91440"/>
+            <a:off x="7579965" y="478631"/>
+            <a:ext cx="1021110" cy="91440"/>
           </a:xfrm>
           <a:prstGeom prst="rect">
             <a:avLst/>
@@ -13242,7 +13242,7 @@
                 <a:ea typeface="Liberation Sans Narrow" pitchFamily="34" charset="-122"/>
                 <a:cs typeface="Liberation Sans Narrow" pitchFamily="34" charset="-120"/>
               </a:rPr>
-              <a:t>RANK 7 CRYPTO GLOBAL</a:t>
+              <a:t>GLOBAL CRYPTO RANK 7</a:t>
             </a:r>
             <a:endParaRPr lang="en-US" sz="800" dirty="0"/>
           </a:p>
@@ -13256,7 +13256,7 @@
         </p:nvSpPr>
         <p:spPr>
           <a:xfrm>
-            <a:off x="7442783" y="476845"/>
+            <a:off x="7444234" y="476845"/>
             <a:ext cx="92869" cy="92869"/>
           </a:xfrm>
           <a:prstGeom prst="rect">
@@ -13295,8 +13295,8 @@
         </p:nvSpPr>
         <p:spPr>
           <a:xfrm>
-            <a:off x="6925977" y="646509"/>
-            <a:ext cx="1901689" cy="164592"/>
+            <a:off x="6779307" y="646509"/>
+            <a:ext cx="2060092" cy="164592"/>
           </a:xfrm>
           <a:prstGeom prst="rect">
             <a:avLst/>
@@ -13319,11 +13319,11 @@
                 <a:solidFill>
                   <a:srgbClr val="A3A3A3"/>
                 </a:solidFill>
-                <a:latin typeface="Liberation Sans Narrow" pitchFamily="34" charset="0"/>
-                <a:ea typeface="Liberation Sans Narrow" pitchFamily="34" charset="-122"/>
-                <a:cs typeface="Liberation Sans Narrow" pitchFamily="34" charset="-120"/>
-              </a:rPr>
-              <a:t>280M POPULASI · 1.8M INVESTOR CRYPTO</a:t>
+                <a:latin typeface="Courier New" pitchFamily="34" charset="0"/>
+                <a:ea typeface="Courier New" pitchFamily="34" charset="-122"/>
+                <a:cs typeface="Courier New" pitchFamily="34" charset="-120"/>
+              </a:rPr>
+              <a:t>280M POPULATION · 1.8M CRYPTO INVESTORS</a:t>
             </a:r>
             <a:endParaRPr lang="en-US" sz="800" dirty="0"/>
           </a:p>
@@ -13402,7 +13402,7 @@
                 <a:ea typeface="Carlito" pitchFamily="34" charset="-122"/>
                 <a:cs typeface="Carlito" pitchFamily="34" charset="-120"/>
               </a:rPr>
-              <a:t>UKURAN PASAR</a:t>
+              <a:t>MARKET SIZE</a:t>
             </a:r>
             <a:endParaRPr lang="en-US" sz="800" dirty="0"/>
           </a:p>
@@ -13768,7 +13768,7 @@
                 <a:ea typeface="Carlito" pitchFamily="34" charset="-122"/>
                 <a:cs typeface="Carlito" pitchFamily="34" charset="-120"/>
               </a:rPr>
-              <a:t>Indonesia UMKM + investor retail</a:t>
+              <a:t>Indonesia MSMEs + retail investors</a:t>
             </a:r>
             <a:endParaRPr lang="en-US" sz="800" dirty="0"/>
           </a:p>
@@ -13966,8 +13966,8 @@
         </p:nvSpPr>
         <p:spPr>
           <a:xfrm>
-            <a:off x="1980047" y="2625551"/>
-            <a:ext cx="877453" cy="164592"/>
+            <a:off x="1928478" y="2625551"/>
+            <a:ext cx="929022" cy="164592"/>
           </a:xfrm>
           <a:prstGeom prst="rect">
             <a:avLst/>
@@ -13996,7 +13996,7 @@
                 <a:ea typeface="Liberation Sans Narrow" pitchFamily="34" charset="-122"/>
                 <a:cs typeface="Liberation Sans Narrow" pitchFamily="34" charset="-120"/>
               </a:rPr>
-              <a:t>Rp 50M / 500 UMKM</a:t>
+              <a:t>Rp 50M / 500 MSMEs</a:t>
             </a:r>
             <a:endParaRPr lang="en-US" sz="800" dirty="0"/>
           </a:p>
@@ -14119,7 +14119,7 @@
                 <a:ea typeface="Carlito" pitchFamily="34" charset="-122"/>
                 <a:cs typeface="Carlito" pitchFamily="34" charset="-120"/>
               </a:rPr>
-              <a:t>UMKM demo onboarded</a:t>
+              <a:t>Demo MSMEs onboarded</a:t>
             </a:r>
             <a:endParaRPr lang="en-US" sz="800" dirty="0"/>
           </a:p>
@@ -14161,7 +14161,7 @@
                 <a:ea typeface="Carlito" pitchFamily="34" charset="-122"/>
                 <a:cs typeface="Carlito" pitchFamily="34" charset="-120"/>
               </a:rPr>
-              <a:t>spans kuliner, kopi, laundry, kerajinan, pertanian</a:t>
+              <a:t>spans culinary, coffee, laundry, crafts, agriculture</a:t>
             </a:r>
             <a:endParaRPr lang="en-US" sz="800" dirty="0"/>
           </a:p>
@@ -14284,7 +14284,7 @@
                 <a:ea typeface="Carlito" pitchFamily="34" charset="-122"/>
                 <a:cs typeface="Carlito" pitchFamily="34" charset="-120"/>
               </a:rPr>
-              <a:t>Sui features aktif dipakai</a:t>
+              <a:t>Sui features actively used</a:t>
             </a:r>
             <a:endParaRPr lang="en-US" sz="800" dirty="0"/>
           </a:p>
@@ -14449,7 +14449,7 @@
                 <a:ea typeface="Carlito" pitchFamily="34" charset="-122"/>
                 <a:cs typeface="Carlito" pitchFamily="34" charset="-120"/>
               </a:rPr>
-              <a:t>PTB finality di testnet</a:t>
+              <a:t>PTB finality on testnet</a:t>
             </a:r>
             <a:endParaRPr lang="en-US" sz="800" dirty="0"/>
           </a:p>
@@ -14491,7 +14491,7 @@
                 <a:ea typeface="Liberation Sans Narrow" pitchFamily="34" charset="-122"/>
                 <a:cs typeface="Liberation Sans Narrow" pitchFamily="34" charset="-120"/>
               </a:rPr>
-              <a:t>distribusi 152 investor atomik</a:t>
+              <a:t>atomic distribution to 152 investors</a:t>
             </a:r>
             <a:endParaRPr lang="en-US" sz="800" dirty="0"/>
           </a:p>
@@ -14614,7 +14614,7 @@
                 <a:ea typeface="Carlito" pitchFamily="34" charset="-122"/>
                 <a:cs typeface="Carlito" pitchFamily="34" charset="-120"/>
               </a:rPr>
-              <a:t>gas cost distribusi</a:t>
+              <a:t>distribution gas cost</a:t>
             </a:r>
             <a:endParaRPr lang="en-US" sz="800" dirty="0"/>
           </a:p>
@@ -14656,7 +14656,7 @@
                 <a:ea typeface="Liberation Sans Narrow" pitchFamily="34" charset="-122"/>
                 <a:cs typeface="Liberation Sans Narrow" pitchFamily="34" charset="-120"/>
               </a:rPr>
-              <a:t>vs $4-12 di Ethereum L1</a:t>
+              <a:t>vs $4-12 on Ethereum L1</a:t>
             </a:r>
             <a:endParaRPr lang="en-US" sz="800" dirty="0"/>
           </a:p>
@@ -14671,7 +14671,7 @@
         <p:spPr>
           <a:xfrm>
             <a:off x="457200" y="4015234"/>
-            <a:ext cx="1847106" cy="189309"/>
+            <a:ext cx="1928701" cy="189309"/>
           </a:xfrm>
           <a:prstGeom prst="roundRect">
             <a:avLst>
@@ -14703,7 +14703,7 @@
         <p:spPr>
           <a:xfrm>
             <a:off x="678656" y="4065240"/>
-            <a:ext cx="1654225" cy="119703"/>
+            <a:ext cx="1735820" cy="119703"/>
           </a:xfrm>
           <a:prstGeom prst="rect">
             <a:avLst/>
@@ -14730,7 +14730,7 @@
                 <a:ea typeface="Carlito" pitchFamily="34" charset="-122"/>
                 <a:cs typeface="Carlito" pitchFamily="34" charset="-120"/>
               </a:rPr>
-              <a:t>Top 10 adopsi crypto global (Indonesia)</a:t>
+              <a:t>Top 10 global crypto adoption (Indonesia)</a:t>
             </a:r>
             <a:endParaRPr lang="en-US" sz="800" dirty="0"/>
           </a:p>
@@ -14783,8 +14783,8 @@
         </p:nvSpPr>
         <p:spPr>
           <a:xfrm>
-            <a:off x="2361456" y="4015234"/>
-            <a:ext cx="1699989" cy="189309"/>
+            <a:off x="2443051" y="4015234"/>
+            <a:ext cx="1904479" cy="189309"/>
           </a:xfrm>
           <a:prstGeom prst="roundRect">
             <a:avLst>
@@ -14815,8 +14815,8 @@
         </p:nvSpPr>
         <p:spPr>
           <a:xfrm>
-            <a:off x="2582912" y="4065240"/>
-            <a:ext cx="1507108" cy="119703"/>
+            <a:off x="2664507" y="4065240"/>
+            <a:ext cx="1711598" cy="119703"/>
           </a:xfrm>
           <a:prstGeom prst="rect">
             <a:avLst/>
@@ -14839,11 +14839,11 @@
                 <a:solidFill>
                   <a:srgbClr val="D97706"/>
                 </a:solidFill>
-                <a:latin typeface="Liberation Sans Narrow" pitchFamily="34" charset="0"/>
-                <a:ea typeface="Liberation Sans Narrow" pitchFamily="34" charset="-122"/>
-                <a:cs typeface="Liberation Sans Narrow" pitchFamily="34" charset="-120"/>
-              </a:rPr>
-              <a:t>1.8M investor crypto Indonesia aktif</a:t>
+                <a:latin typeface="Carlito" pitchFamily="34" charset="0"/>
+                <a:ea typeface="Carlito" pitchFamily="34" charset="-122"/>
+                <a:cs typeface="Carlito" pitchFamily="34" charset="-120"/>
+              </a:rPr>
+              <a:t>1.8M active crypto investors in Indonesia</a:t>
             </a:r>
             <a:endParaRPr lang="en-US" sz="800" dirty="0"/>
           </a:p>
@@ -14857,7 +14857,7 @@
         </p:nvSpPr>
         <p:spPr>
           <a:xfrm>
-            <a:off x="2447181" y="4063454"/>
+            <a:off x="2528776" y="4063454"/>
             <a:ext cx="92869" cy="92869"/>
           </a:xfrm>
           <a:prstGeom prst="rect">
@@ -14896,8 +14896,8 @@
         </p:nvSpPr>
         <p:spPr>
           <a:xfrm>
-            <a:off x="4118595" y="4015234"/>
-            <a:ext cx="1637035" cy="189309"/>
+            <a:off x="4404680" y="4015234"/>
+            <a:ext cx="1628440" cy="189309"/>
           </a:xfrm>
           <a:prstGeom prst="roundRect">
             <a:avLst>
@@ -14928,8 +14928,8 @@
         </p:nvSpPr>
         <p:spPr>
           <a:xfrm>
-            <a:off x="4340051" y="4065240"/>
-            <a:ext cx="4346749" cy="119703"/>
+            <a:off x="4626136" y="4065240"/>
+            <a:ext cx="4060664" cy="119703"/>
           </a:xfrm>
           <a:prstGeom prst="rect">
             <a:avLst/>
@@ -14956,7 +14956,7 @@
                 <a:ea typeface="Liberation Sans Narrow" pitchFamily="34" charset="-122"/>
                 <a:cs typeface="Liberation Sans Narrow" pitchFamily="34" charset="-120"/>
               </a:rPr>
-              <a:t>500 UMKM target pipeline Q1 2026</a:t>
+              <a:t>500 MSME target pipeline Q1 2026</a:t>
             </a:r>
             <a:endParaRPr lang="en-US" sz="800" dirty="0"/>
           </a:p>
@@ -14970,7 +14970,7 @@
         </p:nvSpPr>
         <p:spPr>
           <a:xfrm>
-            <a:off x="4204320" y="4063454"/>
+            <a:off x="4490405" y="4063454"/>
             <a:ext cx="92869" cy="92869"/>
           </a:xfrm>
           <a:prstGeom prst="rect">
@@ -15195,7 +15195,7 @@
                 <a:ea typeface="Carlito" pitchFamily="34" charset="-122"/>
                 <a:cs typeface="Carlito" pitchFamily="34" charset="-120"/>
               </a:rPr>
-              <a:t>Dari hackathon ini ke mainnet dalam 6 bulan.</a:t>
+              <a:t>From this hackathon to mainnet in 6 months.</a:t>
             </a:r>
             <a:endParaRPr lang="en-US" sz="2025" dirty="0"/>
           </a:p>
@@ -15237,7 +15237,7 @@
                 <a:ea typeface="Carlito" pitchFamily="34" charset="-122"/>
                 <a:cs typeface="Carlito" pitchFamily="34" charset="-120"/>
               </a:rPr>
-              <a:t>Arthavest sudah punya MVP lengkap dengan 5 alur. Setelah Sui Overflow, kita deploy ke testnet publik, onboarding UMKM pilot, lalu mainnet dengan DAO jury aktif.</a:t>
+              <a:t>Arthavest already has a complete MVP with 5 flows. After Sui Overflow, we deploy to public testnet, onboard MSME pilots, then mainnet with active DAO jury.</a:t>
             </a:r>
             <a:endParaRPr lang="en-US" sz="800" dirty="0"/>
           </a:p>
@@ -15251,8 +15251,8 @@
         </p:nvSpPr>
         <p:spPr>
           <a:xfrm>
-            <a:off x="7477073" y="417266"/>
-            <a:ext cx="1232587" cy="212027"/>
+            <a:off x="7411440" y="417266"/>
+            <a:ext cx="1298220" cy="212027"/>
           </a:xfrm>
           <a:prstGeom prst="roundRect">
             <a:avLst>
@@ -15283,8 +15283,8 @@
         </p:nvSpPr>
         <p:spPr>
           <a:xfrm>
-            <a:off x="7721389" y="478631"/>
-            <a:ext cx="879686" cy="91440"/>
+            <a:off x="7655756" y="478631"/>
+            <a:ext cx="945319" cy="91440"/>
           </a:xfrm>
           <a:prstGeom prst="rect">
             <a:avLst/>
@@ -15311,7 +15311,7 @@
                 <a:ea typeface="Liberation Sans Narrow" pitchFamily="34" charset="-122"/>
                 <a:cs typeface="Liberation Sans Narrow" pitchFamily="34" charset="-120"/>
               </a:rPr>
-              <a:t>6 BULAN KE MAINNET</a:t>
+              <a:t>6 MONTHS TO MAINNET</a:t>
             </a:r>
             <a:endParaRPr lang="en-US" sz="800" dirty="0"/>
           </a:p>
@@ -15325,7 +15325,7 @@
         </p:nvSpPr>
         <p:spPr>
           <a:xfrm>
-            <a:off x="7585658" y="476845"/>
+            <a:off x="7520025" y="476845"/>
             <a:ext cx="92869" cy="92869"/>
           </a:xfrm>
           <a:prstGeom prst="rect">
@@ -15762,7 +15762,7 @@
                 <a:ea typeface="Carlito" pitchFamily="34" charset="-122"/>
                 <a:cs typeface="Carlito" pitchFamily="34" charset="-120"/>
               </a:rPr>
-              <a:t>5 alur lengkap (marketplace, portfolio, owner, secondary, DAO)</a:t>
+              <a:t>5 complete flows (marketplace, portfolio, owner, secondary, DAO)</a:t>
             </a:r>
             <a:endParaRPr lang="en-US" sz="800" dirty="0"/>
           </a:p>
@@ -15805,7 +15805,7 @@
                 <a:ea typeface="Carlito" pitchFamily="34" charset="-122"/>
                 <a:cs typeface="Carlito" pitchFamily="34" charset="-120"/>
               </a:rPr>
-              <a:t>Move contracts (stream.move + arthavest.move) — belum published</a:t>
+              <a:t>Move contracts (stream.move + arthavest.move) — not yet published</a:t>
             </a:r>
             <a:endParaRPr lang="en-US" sz="800" dirty="0"/>
           </a:p>
@@ -15848,7 +15848,7 @@
                 <a:ea typeface="Liberation Sans Narrow" pitchFamily="34" charset="-122"/>
                 <a:cs typeface="Liberation Sans Narrow" pitchFamily="34" charset="-120"/>
               </a:rPr>
-              <a:t>Demo data 6 UMKM</a:t>
+              <a:t>Demo data 6 MSMEs</a:t>
             </a:r>
             <a:endParaRPr lang="en-US" sz="800" dirty="0"/>
           </a:p>
@@ -16238,7 +16238,7 @@
                 <a:ea typeface="Carlito" pitchFamily="34" charset="-122"/>
                 <a:cs typeface="Carlito" pitchFamily="34" charset="-120"/>
               </a:rPr>
-              <a:t>Publish Move contracts ke Sui testnet</a:t>
+              <a:t>Publish Move contracts to Sui testnet</a:t>
             </a:r>
             <a:endParaRPr lang="en-US" sz="800" dirty="0"/>
           </a:p>
@@ -16281,7 +16281,7 @@
                 <a:ea typeface="Carlito" pitchFamily="34" charset="-122"/>
                 <a:cs typeface="Carlito" pitchFamily="34" charset="-120"/>
               </a:rPr>
-              <a:t>Real @mysten/dapp-kit integration (sudah siap di code)</a:t>
+              <a:t>Real @mysten/dapp-kit integration (already in code)</a:t>
             </a:r>
             <a:endParaRPr lang="en-US" sz="800" dirty="0"/>
           </a:p>
@@ -16324,7 +16324,7 @@
                 <a:ea typeface="Carlito" pitchFamily="34" charset="-122"/>
                 <a:cs typeface="Carlito" pitchFamily="34" charset="-120"/>
               </a:rPr>
-              <a:t>Real Walrus upload untuk dokumen UMKM</a:t>
+              <a:t>Real Walrus upload for MSME documents</a:t>
             </a:r>
             <a:endParaRPr lang="en-US" sz="800" dirty="0"/>
           </a:p>
@@ -16367,7 +16367,7 @@
                 <a:ea typeface="Carlito" pitchFamily="34" charset="-122"/>
                 <a:cs typeface="Carlito" pitchFamily="34" charset="-120"/>
               </a:rPr>
-              <a:t>10 UMKM pilot onboarded (Bandung area)</a:t>
+              <a:t>10 MSME pilots onboarded (Bandung area)</a:t>
             </a:r>
             <a:endParaRPr lang="en-US" sz="800" dirty="0"/>
           </a:p>
@@ -16714,7 +16714,7 @@
                 <a:ea typeface="Liberation Sans Narrow" pitchFamily="34" charset="-122"/>
                 <a:cs typeface="Liberation Sans Narrow" pitchFamily="34" charset="-120"/>
               </a:rPr>
-              <a:t>DAO jury aktif (5 jury terpilih)</a:t>
+              <a:t>Active DAO jury (5 elected jurors)</a:t>
             </a:r>
             <a:endParaRPr lang="en-US" sz="800" dirty="0"/>
           </a:p>
@@ -16800,7 +16800,7 @@
                 <a:ea typeface="Liberation Sans Narrow" pitchFamily="34" charset="-122"/>
                 <a:cs typeface="Liberation Sans Narrow" pitchFamily="34" charset="-120"/>
               </a:rPr>
-              <a:t>Onboarding 100 UMKM (target)</a:t>
+              <a:t>Onboard 100 MSMEs (target)</a:t>
             </a:r>
             <a:endParaRPr lang="en-US" sz="800" dirty="0"/>
           </a:p>
@@ -16843,7 +16843,7 @@
                 <a:ea typeface="Carlito" pitchFamily="34" charset="-122"/>
                 <a:cs typeface="Carlito" pitchFamily="34" charset="-120"/>
               </a:rPr>
-              <a:t>Integrasi payment on-ramp (IDR → SUI)</a:t>
+              <a:t>Payment on-ramp integration (IDR → SUI)</a:t>
             </a:r>
             <a:endParaRPr lang="en-US" sz="800" dirty="0"/>
           </a:p>
@@ -17190,7 +17190,7 @@
                 <a:ea typeface="Carlito" pitchFamily="34" charset="-122"/>
                 <a:cs typeface="Carlito" pitchFamily="34" charset="-120"/>
               </a:rPr>
-              <a:t>Vietnam &amp; Filipina pilot</a:t>
+              <a:t>Vietnam &amp; Philippines pilot</a:t>
             </a:r>
             <a:endParaRPr lang="en-US" sz="800" dirty="0"/>
           </a:p>
@@ -17276,7 +17276,7 @@
                 <a:ea typeface="Carlito" pitchFamily="34" charset="-122"/>
                 <a:cs typeface="Carlito" pitchFamily="34" charset="-120"/>
               </a:rPr>
-              <a:t>SuiStream primitive packaged sebagai SDK open-source</a:t>
+              <a:t>SuiStream primitive packaged as open-source SDK</a:t>
             </a:r>
             <a:endParaRPr lang="en-US" sz="800" dirty="0"/>
           </a:p>
@@ -17319,7 +17319,7 @@
                 <a:ea typeface="Carlito" pitchFamily="34" charset="-122"/>
                 <a:cs typeface="Carlito" pitchFamily="34" charset="-120"/>
               </a:rPr>
-              <a:t>Partnership dengan koperasi UMKM nasional</a:t>
+              <a:t>Partnership with national MSME cooperatives</a:t>
             </a:r>
             <a:endParaRPr lang="en-US" sz="800" dirty="0"/>
           </a:p>
@@ -17410,7 +17410,7 @@
         <p:spPr>
           <a:xfrm>
             <a:off x="807244" y="3287576"/>
-            <a:ext cx="1233440" cy="129731"/>
+            <a:ext cx="1245156" cy="129731"/>
           </a:xfrm>
           <a:prstGeom prst="rect">
             <a:avLst/>
@@ -17439,7 +17439,7 @@
                 <a:ea typeface="Liberation Sans Narrow" pitchFamily="34" charset="-122"/>
                 <a:cs typeface="Liberation Sans Narrow" pitchFamily="34" charset="-120"/>
               </a:rPr>
-              <a:t>6 bulan</a:t>
+              <a:t>6 months</a:t>
             </a:r>
             <a:endParaRPr lang="en-US" sz="1238" dirty="0"/>
           </a:p>
@@ -17454,7 +17454,7 @@
         <p:spPr>
           <a:xfrm>
             <a:off x="807244" y="3444739"/>
-            <a:ext cx="1059987" cy="106710"/>
+            <a:ext cx="1070056" cy="106710"/>
           </a:xfrm>
           <a:prstGeom prst="rect">
             <a:avLst/>
@@ -17481,7 +17481,7 @@
                 <a:ea typeface="Carlito" pitchFamily="34" charset="-122"/>
                 <a:cs typeface="Carlito" pitchFamily="34" charset="-120"/>
               </a:rPr>
-              <a:t>dari hackathon ke mainnet</a:t>
+              <a:t>from hackathon to mainnet</a:t>
             </a:r>
             <a:endParaRPr lang="en-US" sz="800" dirty="0"/>
           </a:p>
@@ -17914,7 +17914,7 @@
         <p:spPr>
           <a:xfrm>
             <a:off x="457200" y="400050"/>
-            <a:ext cx="7705293" cy="164592"/>
+            <a:ext cx="7118934" cy="164592"/>
           </a:xfrm>
           <a:prstGeom prst="rect">
             <a:avLst/>
@@ -17941,7 +17941,7 @@
                 <a:ea typeface="Carlito" pitchFamily="34" charset="-122"/>
                 <a:cs typeface="Carlito" pitchFamily="34" charset="-120"/>
               </a:rPr>
-              <a:t>TIM &amp; ASK</a:t>
+              <a:t>TEAM &amp; ASK</a:t>
             </a:r>
             <a:endParaRPr lang="en-US" sz="800" dirty="0"/>
           </a:p>
@@ -17983,7 +17983,7 @@
                 <a:ea typeface="Carlito" pitchFamily="34" charset="-122"/>
                 <a:cs typeface="Carlito" pitchFamily="34" charset="-120"/>
               </a:rPr>
-              <a:t>Tim builder Indonesia, juri Sui — bantu kami onboard.</a:t>
+              <a:t>Indonesian builder team, Sui jury — help us onboard.</a:t>
             </a:r>
             <a:endParaRPr lang="en-US" sz="2138" dirty="0"/>
           </a:p>
@@ -17997,8 +17997,8 @@
         </p:nvSpPr>
         <p:spPr>
           <a:xfrm>
-            <a:off x="7707570" y="431554"/>
-            <a:ext cx="1002090" cy="212027"/>
+            <a:off x="7725095" y="431554"/>
+            <a:ext cx="984565" cy="212027"/>
           </a:xfrm>
           <a:prstGeom prst="roundRect">
             <a:avLst>
@@ -18029,8 +18029,8 @@
         </p:nvSpPr>
         <p:spPr>
           <a:xfrm>
-            <a:off x="7951887" y="492919"/>
-            <a:ext cx="649188" cy="91440"/>
+            <a:off x="7969411" y="492919"/>
+            <a:ext cx="631664" cy="91440"/>
           </a:xfrm>
           <a:prstGeom prst="rect">
             <a:avLst/>
@@ -18057,7 +18057,7 @@
                 <a:ea typeface="Carlito" pitchFamily="34" charset="-122"/>
                 <a:cs typeface="Carlito" pitchFamily="34" charset="-120"/>
               </a:rPr>
-              <a:t>SLIDE PENUTUP</a:t>
+              <a:t>CLOSING SLIDE</a:t>
             </a:r>
             <a:endParaRPr lang="en-US" sz="800" dirty="0"/>
           </a:p>
@@ -18071,7 +18071,7 @@
         </p:nvSpPr>
         <p:spPr>
           <a:xfrm>
-            <a:off x="7816155" y="491133"/>
+            <a:off x="7833680" y="491133"/>
             <a:ext cx="92869" cy="92869"/>
           </a:xfrm>
           <a:prstGeom prst="rect">
@@ -18110,8 +18110,8 @@
         </p:nvSpPr>
         <p:spPr>
           <a:xfrm>
-            <a:off x="8099785" y="660797"/>
-            <a:ext cx="709651" cy="164592"/>
+            <a:off x="8246566" y="660797"/>
+            <a:ext cx="579750" cy="164592"/>
           </a:xfrm>
           <a:prstGeom prst="rect">
             <a:avLst/>
@@ -18138,7 +18138,7 @@
                 <a:ea typeface="Courier New" pitchFamily="34" charset="-122"/>
                 <a:cs typeface="Courier New" pitchFamily="34" charset="-120"/>
               </a:rPr>
-              <a:t>TERIMA KASIH</a:t>
+              <a:t>THANK YOU</a:t>
             </a:r>
             <a:endParaRPr lang="en-US" sz="800" dirty="0"/>
           </a:p>
@@ -18153,7 +18153,7 @@
         <p:spPr>
           <a:xfrm>
             <a:off x="628650" y="1377851"/>
-            <a:ext cx="336828" cy="131159"/>
+            <a:ext cx="547390" cy="131159"/>
           </a:xfrm>
           <a:prstGeom prst="rect">
             <a:avLst/>
@@ -18180,7 +18180,7 @@
                 <a:ea typeface="Carlito" pitchFamily="34" charset="-122"/>
                 <a:cs typeface="Carlito" pitchFamily="34" charset="-120"/>
               </a:rPr>
-              <a:t>TIM</a:t>
+              <a:t>TEAM</a:t>
             </a:r>
             <a:endParaRPr lang="en-US" sz="900" dirty="0"/>
           </a:p>
@@ -19096,7 +19096,7 @@
         <p:spPr>
           <a:xfrm>
             <a:off x="4478238" y="1377851"/>
-            <a:ext cx="1366333" cy="131159"/>
+            <a:ext cx="1231269" cy="131159"/>
           </a:xfrm>
           <a:prstGeom prst="rect">
             <a:avLst/>
@@ -19123,7 +19123,7 @@
                 <a:ea typeface="Carlito" pitchFamily="34" charset="-122"/>
                 <a:cs typeface="Carlito" pitchFamily="34" charset="-120"/>
               </a:rPr>
-              <a:t>YANG KITA MINTA</a:t>
+              <a:t>WHAT WE NEED</a:t>
             </a:r>
             <a:endParaRPr lang="en-US" sz="900" dirty="0"/>
           </a:p>
@@ -19356,7 +19356,7 @@
                 <a:ea typeface="Carlito" pitchFamily="34" charset="-122"/>
                 <a:cs typeface="Carlito" pitchFamily="34" charset="-120"/>
               </a:rPr>
-              <a:t>Visibility + grant untuk audit smart contract + mainnet deployment cost</a:t>
+              <a:t>Visibility + grant for smart contract audit + mainnet deployment cost</a:t>
             </a:r>
             <a:endParaRPr lang="en-US" sz="800" dirty="0"/>
           </a:p>
@@ -19479,16 +19479,16 @@
         <p:spPr>
           <a:xfrm>
             <a:off x="4771132" y="2227957"/>
-            <a:ext cx="3808400" cy="113992"/>
-          </a:xfrm>
-          <a:prstGeom prst="rect">
-            <a:avLst/>
-          </a:prstGeom>
-          <a:noFill/>
-          <a:ln/>
-        </p:spPr>
-        <p:txBody>
-          <a:bodyPr wrap="none" lIns="0" tIns="0" rIns="0" bIns="0" rtlCol="0" anchor="t">
+            <a:ext cx="3918128" cy="113992"/>
+          </a:xfrm>
+          <a:prstGeom prst="rect">
+            <a:avLst/>
+          </a:prstGeom>
+          <a:noFill/>
+          <a:ln/>
+        </p:spPr>
+        <p:txBody>
+          <a:bodyPr wrap="square" lIns="0" tIns="0" rIns="0" bIns="0" rtlCol="0" anchor="t">
             <a:normAutofit/>
           </a:bodyPr>
           <a:lstStyle/>
@@ -19508,7 +19508,7 @@
                 <a:ea typeface="Carlito" pitchFamily="34" charset="-122"/>
                 <a:cs typeface="Carlito" pitchFamily="34" charset="-120"/>
               </a:rPr>
-              <a:t>Intro ke koperasi UMKM</a:t>
+              <a:t>Intro to MSME cooperatives</a:t>
             </a:r>
             <a:endParaRPr lang="en-US" sz="800" dirty="0"/>
           </a:p>
@@ -19550,7 +19550,7 @@
                 <a:ea typeface="Carlito" pitchFamily="34" charset="-122"/>
                 <a:cs typeface="Carlito" pitchFamily="34" charset="-120"/>
               </a:rPr>
-              <a:t>Pipeline 100+ UMKM pilot — kamu yang kenal ekosistem Indonesia?</a:t>
+              <a:t>Pipeline of 100+ MSME pilots — do you know the Indonesian ecosystem?</a:t>
             </a:r>
             <a:endParaRPr lang="en-US" sz="800" dirty="0"/>
           </a:p>
@@ -19744,7 +19744,7 @@
                 <a:ea typeface="Carlito" pitchFamily="34" charset="-122"/>
                 <a:cs typeface="Carlito" pitchFamily="34" charset="-120"/>
               </a:rPr>
-              <a:t>Primitive kami open-source — feedback dari Sui core team akan shape roadmap SDK</a:t>
+              <a:t>Our primitive is open-source — feedback from Sui core team will shape SDK roadmap</a:t>
             </a:r>
             <a:endParaRPr lang="en-US" sz="800" dirty="0"/>
           </a:p>
@@ -19864,7 +19864,7 @@
         <p:spPr>
           <a:xfrm>
             <a:off x="878681" y="3337024"/>
-            <a:ext cx="1628407" cy="141116"/>
+            <a:ext cx="1574418" cy="141116"/>
           </a:xfrm>
           <a:prstGeom prst="rect">
             <a:avLst/>
@@ -19893,7 +19893,7 @@
                 <a:ea typeface="Carlito" pitchFamily="34" charset="-122"/>
                 <a:cs typeface="Carlito" pitchFamily="34" charset="-120"/>
               </a:rPr>
-              <a:t>Coba live demo sekarang</a:t>
+              <a:t>Try the live demo now</a:t>
             </a:r>
             <a:endParaRPr lang="en-US" sz="1013" dirty="0"/>
           </a:p>
@@ -19908,7 +19908,7 @@
         <p:spPr>
           <a:xfrm>
             <a:off x="878681" y="3505572"/>
-            <a:ext cx="1674933" cy="128588"/>
+            <a:ext cx="1450829" cy="128588"/>
           </a:xfrm>
           <a:prstGeom prst="rect">
             <a:avLst/>
@@ -19949,8 +19949,8 @@
         </p:nvSpPr>
         <p:spPr>
           <a:xfrm>
-            <a:off x="7398380" y="3326343"/>
-            <a:ext cx="1161261" cy="318497"/>
+            <a:off x="7398492" y="3326343"/>
+            <a:ext cx="1161150" cy="318497"/>
           </a:xfrm>
           <a:prstGeom prst="roundRect">
             <a:avLst>
@@ -19981,8 +19981,8 @@
         </p:nvSpPr>
         <p:spPr>
           <a:xfrm>
-            <a:off x="7564115" y="3424870"/>
-            <a:ext cx="672629" cy="114300"/>
+            <a:off x="7564227" y="3424870"/>
+            <a:ext cx="672517" cy="114300"/>
           </a:xfrm>
           <a:prstGeom prst="rect">
             <a:avLst/>
@@ -20009,7 +20009,7 @@
                 <a:ea typeface="Carlito" pitchFamily="34" charset="-122"/>
                 <a:cs typeface="Carlito" pitchFamily="34" charset="-120"/>
               </a:rPr>
-              <a:t>Jelajahi Demo</a:t>
+              <a:t>Explore Demo</a:t>
             </a:r>
             <a:endParaRPr lang="en-US" sz="800" dirty="0"/>
           </a:p>
@@ -20090,7 +20090,7 @@
                 <a:ea typeface="Carlito" pitchFamily="34" charset="-122"/>
                 <a:cs typeface="Carlito" pitchFamily="34" charset="-120"/>
               </a:rPr>
-              <a:t>Arthavest · Sui Overflow 2025 · Terima kasih</a:t>
+              <a:t>Arthavest · Sui Overflow 2025 · Thank you</a:t>
             </a:r>
             <a:endParaRPr lang="en-US" sz="800" dirty="0"/>
           </a:p>

</xml_diff>